<commit_message>
System Design vi: sd-14-022 deck decodes STRIDE and LINDDUN on the last slide
Co-Authored-By: Claude Sonnet 5.5 <noreply@anthropic.com>
Claude-Session: https://claude.ai/code/session_01WnjciXNJBLEd8jy3HrG49S
</commit_message>
<xml_diff>
--- a/system-design-101/vi/lessons/sd-14-022/slides/sd-14-022.pptx
+++ b/system-design-101/vi/lessons/sd-14-022/slides/sd-14-022.pptx
@@ -3314,11 +3314,11 @@
         <p:spPr>
           <a:xfrm>
             <a:off x="914400" y="1485900"/>
-            <a:ext cx="4000500" cy="1943100"/>
+            <a:ext cx="3171825" cy="2095500"/>
           </a:xfrm>
           <a:prstGeom prst="roundRect">
             <a:avLst>
-              <a:gd name="adj" fmla="val 10784"/>
+              <a:gd name="adj" fmla="val 10000"/>
             </a:avLst>
           </a:prstGeom>
           <a:solidFill>
@@ -3335,8 +3335,8 @@
         </p:nvSpPr>
         <p:spPr>
           <a:xfrm>
-            <a:off x="1143000" y="1695450"/>
-            <a:ext cx="3543300" cy="419100"/>
+            <a:off x="1104900" y="1638300"/>
+            <a:ext cx="2790825" cy="419100"/>
           </a:xfrm>
           <a:prstGeom prst="rect">
             <a:avLst/>
@@ -3374,8 +3374,8 @@
         </p:nvSpPr>
         <p:spPr>
           <a:xfrm>
-            <a:off x="1143000" y="2171700"/>
-            <a:ext cx="3543300" cy="571500"/>
+            <a:off x="1104900" y="2076450"/>
+            <a:ext cx="2790825" cy="800100"/>
           </a:xfrm>
           <a:prstGeom prst="rect">
             <a:avLst/>
@@ -3438,8 +3438,8 @@
         </p:nvSpPr>
         <p:spPr>
           <a:xfrm>
-            <a:off x="1143000" y="2876550"/>
-            <a:ext cx="3543300" cy="342900"/>
+            <a:off x="1104900" y="2933700"/>
+            <a:ext cx="2790825" cy="590550"/>
           </a:xfrm>
           <a:prstGeom prst="rect">
             <a:avLst/>
@@ -3524,12 +3524,12 @@
         </p:nvSpPr>
         <p:spPr>
           <a:xfrm>
-            <a:off x="5067300" y="1485900"/>
-            <a:ext cx="4000500" cy="1943100"/>
+            <a:off x="4238625" y="1485900"/>
+            <a:ext cx="3171825" cy="2095500"/>
           </a:xfrm>
           <a:prstGeom prst="roundRect">
             <a:avLst>
-              <a:gd name="adj" fmla="val 10784"/>
+              <a:gd name="adj" fmla="val 10000"/>
             </a:avLst>
           </a:prstGeom>
           <a:solidFill>
@@ -3546,8 +3546,8 @@
         </p:nvSpPr>
         <p:spPr>
           <a:xfrm>
-            <a:off x="5295900" y="1695450"/>
-            <a:ext cx="3543300" cy="419100"/>
+            <a:off x="4429125" y="1638300"/>
+            <a:ext cx="2790825" cy="419100"/>
           </a:xfrm>
           <a:prstGeom prst="rect">
             <a:avLst/>
@@ -3585,8 +3585,8 @@
         </p:nvSpPr>
         <p:spPr>
           <a:xfrm>
-            <a:off x="5295900" y="2171700"/>
-            <a:ext cx="3543300" cy="571500"/>
+            <a:off x="4429125" y="2076450"/>
+            <a:ext cx="2790825" cy="800100"/>
           </a:xfrm>
           <a:prstGeom prst="rect">
             <a:avLst/>
@@ -3649,8 +3649,8 @@
         </p:nvSpPr>
         <p:spPr>
           <a:xfrm>
-            <a:off x="5295900" y="2876550"/>
-            <a:ext cx="3543300" cy="342900"/>
+            <a:off x="4429125" y="2933700"/>
+            <a:ext cx="2790825" cy="590550"/>
           </a:xfrm>
           <a:prstGeom prst="rect">
             <a:avLst/>
@@ -3757,12 +3757,12 @@
         </p:nvSpPr>
         <p:spPr>
           <a:xfrm>
-            <a:off x="9220200" y="1485900"/>
-            <a:ext cx="4000500" cy="1943100"/>
+            <a:off x="7562850" y="1485900"/>
+            <a:ext cx="3171825" cy="2095500"/>
           </a:xfrm>
           <a:prstGeom prst="roundRect">
             <a:avLst>
-              <a:gd name="adj" fmla="val 10784"/>
+              <a:gd name="adj" fmla="val 10000"/>
             </a:avLst>
           </a:prstGeom>
           <a:solidFill>
@@ -3779,8 +3779,8 @@
         </p:nvSpPr>
         <p:spPr>
           <a:xfrm>
-            <a:off x="9448800" y="1695450"/>
-            <a:ext cx="3543300" cy="419100"/>
+            <a:off x="7753350" y="1638300"/>
+            <a:ext cx="2790825" cy="419100"/>
           </a:xfrm>
           <a:prstGeom prst="rect">
             <a:avLst/>
@@ -3818,8 +3818,8 @@
         </p:nvSpPr>
         <p:spPr>
           <a:xfrm>
-            <a:off x="9448800" y="2171700"/>
-            <a:ext cx="3543300" cy="571500"/>
+            <a:off x="7753350" y="2076450"/>
+            <a:ext cx="2790825" cy="800100"/>
           </a:xfrm>
           <a:prstGeom prst="rect">
             <a:avLst/>
@@ -3893,8 +3893,8 @@
         </p:nvSpPr>
         <p:spPr>
           <a:xfrm>
-            <a:off x="9448800" y="2876550"/>
-            <a:ext cx="3543300" cy="342900"/>
+            <a:off x="7753350" y="2933700"/>
+            <a:ext cx="2790825" cy="590550"/>
           </a:xfrm>
           <a:prstGeom prst="rect">
             <a:avLst/>
@@ -4001,12 +4001,12 @@
         </p:nvSpPr>
         <p:spPr>
           <a:xfrm>
-            <a:off x="13373100" y="1485900"/>
-            <a:ext cx="4000500" cy="1943100"/>
+            <a:off x="10887075" y="1485900"/>
+            <a:ext cx="3171825" cy="2095500"/>
           </a:xfrm>
           <a:prstGeom prst="roundRect">
             <a:avLst>
-              <a:gd name="adj" fmla="val 10784"/>
+              <a:gd name="adj" fmla="val 10000"/>
             </a:avLst>
           </a:prstGeom>
           <a:solidFill>
@@ -4023,8 +4023,8 @@
         </p:nvSpPr>
         <p:spPr>
           <a:xfrm>
-            <a:off x="13601700" y="1695450"/>
-            <a:ext cx="3543300" cy="419100"/>
+            <a:off x="11077575" y="1638300"/>
+            <a:ext cx="2790825" cy="419100"/>
           </a:xfrm>
           <a:prstGeom prst="rect">
             <a:avLst/>
@@ -4062,8 +4062,8 @@
         </p:nvSpPr>
         <p:spPr>
           <a:xfrm>
-            <a:off x="13601700" y="2171700"/>
-            <a:ext cx="3543300" cy="571500"/>
+            <a:off x="11077575" y="2076450"/>
+            <a:ext cx="2790825" cy="800100"/>
           </a:xfrm>
           <a:prstGeom prst="rect">
             <a:avLst/>
@@ -4126,8 +4126,8 @@
         </p:nvSpPr>
         <p:spPr>
           <a:xfrm>
-            <a:off x="13601700" y="2876550"/>
-            <a:ext cx="3543300" cy="342900"/>
+            <a:off x="11077575" y="2933700"/>
+            <a:ext cx="2790825" cy="590550"/>
           </a:xfrm>
           <a:prstGeom prst="rect">
             <a:avLst/>
@@ -4201,12 +4201,12 @@
         </p:nvSpPr>
         <p:spPr>
           <a:xfrm>
-            <a:off x="914400" y="3581400"/>
-            <a:ext cx="4000500" cy="1943100"/>
+            <a:off x="14211300" y="1485900"/>
+            <a:ext cx="3162300" cy="2095500"/>
           </a:xfrm>
           <a:prstGeom prst="roundRect">
             <a:avLst>
-              <a:gd name="adj" fmla="val 10784"/>
+              <a:gd name="adj" fmla="val 10000"/>
             </a:avLst>
           </a:prstGeom>
           <a:solidFill>
@@ -4223,8 +4223,8 @@
         </p:nvSpPr>
         <p:spPr>
           <a:xfrm>
-            <a:off x="1143000" y="3790950"/>
-            <a:ext cx="3543300" cy="419100"/>
+            <a:off x="14401800" y="1638300"/>
+            <a:ext cx="2781300" cy="419100"/>
           </a:xfrm>
           <a:prstGeom prst="rect">
             <a:avLst/>
@@ -4262,8 +4262,8 @@
         </p:nvSpPr>
         <p:spPr>
           <a:xfrm>
-            <a:off x="1143000" y="4267200"/>
-            <a:ext cx="3543300" cy="571500"/>
+            <a:off x="14401800" y="2076450"/>
+            <a:ext cx="2781300" cy="800100"/>
           </a:xfrm>
           <a:prstGeom prst="rect">
             <a:avLst/>
@@ -4304,8 +4304,8 @@
         </p:nvSpPr>
         <p:spPr>
           <a:xfrm>
-            <a:off x="1143000" y="4972050"/>
-            <a:ext cx="3543300" cy="342900"/>
+            <a:off x="14401800" y="2933700"/>
+            <a:ext cx="2781300" cy="590550"/>
           </a:xfrm>
           <a:prstGeom prst="rect">
             <a:avLst/>
@@ -4412,12 +4412,12 @@
         </p:nvSpPr>
         <p:spPr>
           <a:xfrm>
-            <a:off x="5067300" y="3581400"/>
-            <a:ext cx="4000500" cy="1943100"/>
+            <a:off x="914400" y="3733800"/>
+            <a:ext cx="3171825" cy="2095500"/>
           </a:xfrm>
           <a:prstGeom prst="roundRect">
             <a:avLst>
-              <a:gd name="adj" fmla="val 10784"/>
+              <a:gd name="adj" fmla="val 10000"/>
             </a:avLst>
           </a:prstGeom>
           <a:solidFill>
@@ -4434,8 +4434,8 @@
         </p:nvSpPr>
         <p:spPr>
           <a:xfrm>
-            <a:off x="5295900" y="3790950"/>
-            <a:ext cx="3543300" cy="419100"/>
+            <a:off x="1104900" y="3886200"/>
+            <a:ext cx="2790825" cy="419100"/>
           </a:xfrm>
           <a:prstGeom prst="rect">
             <a:avLst/>
@@ -4473,8 +4473,8 @@
         </p:nvSpPr>
         <p:spPr>
           <a:xfrm>
-            <a:off x="5295900" y="4267200"/>
-            <a:ext cx="3543300" cy="571500"/>
+            <a:off x="1104900" y="4324350"/>
+            <a:ext cx="2790825" cy="800100"/>
           </a:xfrm>
           <a:prstGeom prst="rect">
             <a:avLst/>
@@ -4526,8 +4526,8 @@
         </p:nvSpPr>
         <p:spPr>
           <a:xfrm>
-            <a:off x="5295900" y="4972050"/>
-            <a:ext cx="3543300" cy="342900"/>
+            <a:off x="1104900" y="5181600"/>
+            <a:ext cx="2790825" cy="590550"/>
           </a:xfrm>
           <a:prstGeom prst="rect">
             <a:avLst/>
@@ -4645,12 +4645,12 @@
         </p:nvSpPr>
         <p:spPr>
           <a:xfrm>
-            <a:off x="9220200" y="3581400"/>
-            <a:ext cx="4000500" cy="1943100"/>
+            <a:off x="4238625" y="3733800"/>
+            <a:ext cx="3171825" cy="2095500"/>
           </a:xfrm>
           <a:prstGeom prst="roundRect">
             <a:avLst>
-              <a:gd name="adj" fmla="val 10784"/>
+              <a:gd name="adj" fmla="val 10000"/>
             </a:avLst>
           </a:prstGeom>
           <a:solidFill>
@@ -4667,8 +4667,8 @@
         </p:nvSpPr>
         <p:spPr>
           <a:xfrm>
-            <a:off x="9448800" y="3790950"/>
-            <a:ext cx="3543300" cy="419100"/>
+            <a:off x="4429125" y="3886200"/>
+            <a:ext cx="2790825" cy="419100"/>
           </a:xfrm>
           <a:prstGeom prst="rect">
             <a:avLst/>
@@ -4706,8 +4706,8 @@
         </p:nvSpPr>
         <p:spPr>
           <a:xfrm>
-            <a:off x="9448800" y="4267200"/>
-            <a:ext cx="3543300" cy="571500"/>
+            <a:off x="4429125" y="4324350"/>
+            <a:ext cx="2790825" cy="800100"/>
           </a:xfrm>
           <a:prstGeom prst="rect">
             <a:avLst/>
@@ -4770,8 +4770,8 @@
         </p:nvSpPr>
         <p:spPr>
           <a:xfrm>
-            <a:off x="9448800" y="4972050"/>
-            <a:ext cx="3543300" cy="342900"/>
+            <a:off x="4429125" y="5181600"/>
+            <a:ext cx="2790825" cy="590550"/>
           </a:xfrm>
           <a:prstGeom prst="rect">
             <a:avLst/>
@@ -4867,12 +4867,12 @@
         </p:nvSpPr>
         <p:spPr>
           <a:xfrm>
-            <a:off x="13373100" y="3581400"/>
-            <a:ext cx="4000500" cy="1943100"/>
+            <a:off x="7562850" y="3733800"/>
+            <a:ext cx="3171825" cy="2095500"/>
           </a:xfrm>
           <a:prstGeom prst="roundRect">
             <a:avLst>
-              <a:gd name="adj" fmla="val 10784"/>
+              <a:gd name="adj" fmla="val 10000"/>
             </a:avLst>
           </a:prstGeom>
           <a:solidFill>
@@ -4889,8 +4889,8 @@
         </p:nvSpPr>
         <p:spPr>
           <a:xfrm>
-            <a:off x="13601700" y="3790950"/>
-            <a:ext cx="3543300" cy="419100"/>
+            <a:off x="7753350" y="3886200"/>
+            <a:ext cx="2790825" cy="419100"/>
           </a:xfrm>
           <a:prstGeom prst="rect">
             <a:avLst/>
@@ -4928,8 +4928,8 @@
         </p:nvSpPr>
         <p:spPr>
           <a:xfrm>
-            <a:off x="13601700" y="4267200"/>
-            <a:ext cx="3543300" cy="571500"/>
+            <a:off x="7753350" y="4324350"/>
+            <a:ext cx="2790825" cy="800100"/>
           </a:xfrm>
           <a:prstGeom prst="rect">
             <a:avLst/>
@@ -5014,8 +5014,8 @@
         </p:nvSpPr>
         <p:spPr>
           <a:xfrm>
-            <a:off x="13601700" y="4972050"/>
-            <a:ext cx="3543300" cy="342900"/>
+            <a:off x="7753350" y="5181600"/>
+            <a:ext cx="2790825" cy="590550"/>
           </a:xfrm>
           <a:prstGeom prst="rect">
             <a:avLst/>
@@ -5111,12 +5111,12 @@
         </p:nvSpPr>
         <p:spPr>
           <a:xfrm>
-            <a:off x="914400" y="5676900"/>
-            <a:ext cx="4000500" cy="1943100"/>
+            <a:off x="10887075" y="3733800"/>
+            <a:ext cx="3171825" cy="2095500"/>
           </a:xfrm>
           <a:prstGeom prst="roundRect">
             <a:avLst>
-              <a:gd name="adj" fmla="val 10784"/>
+              <a:gd name="adj" fmla="val 10000"/>
             </a:avLst>
           </a:prstGeom>
           <a:solidFill>
@@ -5133,8 +5133,8 @@
         </p:nvSpPr>
         <p:spPr>
           <a:xfrm>
-            <a:off x="1143000" y="5886450"/>
-            <a:ext cx="3543300" cy="419100"/>
+            <a:off x="11077575" y="3886200"/>
+            <a:ext cx="2790825" cy="419100"/>
           </a:xfrm>
           <a:prstGeom prst="rect">
             <a:avLst/>
@@ -5172,8 +5172,8 @@
         </p:nvSpPr>
         <p:spPr>
           <a:xfrm>
-            <a:off x="1143000" y="6362700"/>
-            <a:ext cx="3543300" cy="571500"/>
+            <a:off x="11077575" y="4324350"/>
+            <a:ext cx="2790825" cy="800100"/>
           </a:xfrm>
           <a:prstGeom prst="rect">
             <a:avLst/>
@@ -5247,8 +5247,8 @@
         </p:nvSpPr>
         <p:spPr>
           <a:xfrm>
-            <a:off x="1143000" y="7067550"/>
-            <a:ext cx="3543300" cy="342900"/>
+            <a:off x="11077575" y="5181600"/>
+            <a:ext cx="2790825" cy="590550"/>
           </a:xfrm>
           <a:prstGeom prst="rect">
             <a:avLst/>
@@ -5355,12 +5355,12 @@
         </p:nvSpPr>
         <p:spPr>
           <a:xfrm>
-            <a:off x="5067300" y="5676900"/>
-            <a:ext cx="4000500" cy="1943100"/>
+            <a:off x="14211300" y="3733800"/>
+            <a:ext cx="3162300" cy="2095500"/>
           </a:xfrm>
           <a:prstGeom prst="roundRect">
             <a:avLst>
-              <a:gd name="adj" fmla="val 10784"/>
+              <a:gd name="adj" fmla="val 10000"/>
             </a:avLst>
           </a:prstGeom>
           <a:solidFill>
@@ -5377,8 +5377,8 @@
         </p:nvSpPr>
         <p:spPr>
           <a:xfrm>
-            <a:off x="5295900" y="5886450"/>
-            <a:ext cx="3543300" cy="419100"/>
+            <a:off x="14401800" y="3886200"/>
+            <a:ext cx="2781300" cy="419100"/>
           </a:xfrm>
           <a:prstGeom prst="rect">
             <a:avLst/>
@@ -5416,8 +5416,8 @@
         </p:nvSpPr>
         <p:spPr>
           <a:xfrm>
-            <a:off x="5295900" y="6362700"/>
-            <a:ext cx="3543300" cy="571500"/>
+            <a:off x="14401800" y="4324350"/>
+            <a:ext cx="2781300" cy="800100"/>
           </a:xfrm>
           <a:prstGeom prst="rect">
             <a:avLst/>
@@ -5480,8 +5480,8 @@
         </p:nvSpPr>
         <p:spPr>
           <a:xfrm>
-            <a:off x="5295900" y="7067550"/>
-            <a:ext cx="3543300" cy="342900"/>
+            <a:off x="14401800" y="5181600"/>
+            <a:ext cx="2781300" cy="590550"/>
           </a:xfrm>
           <a:prstGeom prst="rect">
             <a:avLst/>
@@ -5577,12 +5577,12 @@
         </p:nvSpPr>
         <p:spPr>
           <a:xfrm>
-            <a:off x="9220200" y="5676900"/>
-            <a:ext cx="4000500" cy="1943100"/>
+            <a:off x="914400" y="5981700"/>
+            <a:ext cx="8153400" cy="1657350"/>
           </a:xfrm>
           <a:prstGeom prst="roundRect">
             <a:avLst>
-              <a:gd name="adj" fmla="val 10784"/>
+              <a:gd name="adj" fmla="val 12644"/>
             </a:avLst>
           </a:prstGeom>
           <a:solidFill>
@@ -5599,8 +5599,8 @@
         </p:nvSpPr>
         <p:spPr>
           <a:xfrm>
-            <a:off x="9448800" y="5886450"/>
-            <a:ext cx="3543300" cy="419100"/>
+            <a:off x="1143000" y="6134100"/>
+            <a:ext cx="7696200" cy="419100"/>
           </a:xfrm>
           <a:prstGeom prst="rect">
             <a:avLst/>
@@ -5638,8 +5638,8 @@
         </p:nvSpPr>
         <p:spPr>
           <a:xfrm>
-            <a:off x="9448800" y="6362700"/>
-            <a:ext cx="3543300" cy="571500"/>
+            <a:off x="1143000" y="6591300"/>
+            <a:ext cx="7696200" cy="571500"/>
           </a:xfrm>
           <a:prstGeom prst="rect">
             <a:avLst/>
@@ -5658,6 +5658,28 @@
               <a:buNone/>
             </a:pPr>
             <a:r>
+              <a:rPr lang="en-US" sz="1650" dirty="0" spc="-3" kern="0">
+                <a:solidFill>
+                  <a:srgbClr val="9A98A0"/>
+                </a:solidFill>
+                <a:latin typeface="Be Vietnam Pro" pitchFamily="34" charset="0"/>
+                <a:ea typeface="Be Vietnam Pro" pitchFamily="34" charset="-122"/>
+                <a:cs typeface="Be Vietnam Pro" pitchFamily="34" charset="-120"/>
+              </a:rPr>
+              <a:t>Spoofing,</a:t>
+            </a:r>
+            <a:r>
+              <a:rPr lang="en-US" sz="1650" dirty="0" spc="-12" kern="0">
+                <a:solidFill>
+                  <a:srgbClr val="9A98A0"/>
+                </a:solidFill>
+                <a:latin typeface="Be Vietnam Pro" pitchFamily="34" charset="0"/>
+                <a:ea typeface="Be Vietnam Pro" pitchFamily="34" charset="-122"/>
+                <a:cs typeface="Be Vietnam Pro" pitchFamily="34" charset="-120"/>
+              </a:rPr>
+              <a:t> Tampering,</a:t>
+            </a:r>
+            <a:r>
               <a:rPr lang="en-US" sz="1650" dirty="0" spc="-9" kern="0">
                 <a:solidFill>
                   <a:srgbClr val="9A98A0"/>
@@ -5666,7 +5688,29 @@
                 <a:ea typeface="Be Vietnam Pro" pitchFamily="34" charset="-122"/>
                 <a:cs typeface="Be Vietnam Pro" pitchFamily="34" charset="-120"/>
               </a:rPr>
-              <a:t>tên</a:t>
+              <a:t> Repudiation,</a:t>
+            </a:r>
+            <a:r>
+              <a:rPr lang="en-US" sz="1650" dirty="0" spc="-8" kern="0">
+                <a:solidFill>
+                  <a:srgbClr val="9A98A0"/>
+                </a:solidFill>
+                <a:latin typeface="Be Vietnam Pro" pitchFamily="34" charset="0"/>
+                <a:ea typeface="Be Vietnam Pro" pitchFamily="34" charset="-122"/>
+                <a:cs typeface="Be Vietnam Pro" pitchFamily="34" charset="-120"/>
+              </a:rPr>
+              <a:t> Information disclosure,</a:t>
+            </a:r>
+            <a:r>
+              <a:rPr lang="en-US" sz="1650" dirty="0" spc="-1" kern="0">
+                <a:solidFill>
+                  <a:srgbClr val="9A98A0"/>
+                </a:solidFill>
+                <a:latin typeface="Be Vietnam Pro" pitchFamily="34" charset="0"/>
+                <a:ea typeface="Be Vietnam Pro" pitchFamily="34" charset="-122"/>
+                <a:cs typeface="Be Vietnam Pro" pitchFamily="34" charset="-120"/>
+              </a:rPr>
+              <a:t> Denial</a:t>
             </a:r>
             <a:r>
               <a:rPr lang="en-US" sz="1650" dirty="0" spc="0" kern="0">
@@ -5677,7 +5721,29 @@
                 <a:ea typeface="Be Vietnam Pro" pitchFamily="34" charset="-122"/>
                 <a:cs typeface="Be Vietnam Pro" pitchFamily="34" charset="-120"/>
               </a:rPr>
-              <a:t> khung do</a:t>
+              <a:t> of</a:t>
+            </a:r>
+            <a:r>
+              <a:rPr lang="en-US" sz="1650" dirty="0" spc="-2" kern="0">
+                <a:solidFill>
+                  <a:srgbClr val="9A98A0"/>
+                </a:solidFill>
+                <a:latin typeface="Be Vietnam Pro" pitchFamily="34" charset="0"/>
+                <a:ea typeface="Be Vietnam Pro" pitchFamily="34" charset="-122"/>
+                <a:cs typeface="Be Vietnam Pro" pitchFamily="34" charset="-120"/>
+              </a:rPr>
+              <a:t> service,</a:t>
+            </a:r>
+            <a:r>
+              <a:rPr lang="en-US" sz="1650" dirty="0" spc="-10" kern="0">
+                <a:solidFill>
+                  <a:srgbClr val="9A98A0"/>
+                </a:solidFill>
+                <a:latin typeface="Be Vietnam Pro" pitchFamily="34" charset="0"/>
+                <a:ea typeface="Be Vietnam Pro" pitchFamily="34" charset="-122"/>
+                <a:cs typeface="Be Vietnam Pro" pitchFamily="34" charset="-120"/>
+              </a:rPr>
+              <a:t> Elevation</a:t>
             </a:r>
             <a:r>
               <a:rPr lang="en-US" sz="1650" dirty="0" spc="-1" kern="0">
@@ -5688,29 +5754,7 @@
                 <a:ea typeface="Be Vietnam Pro" pitchFamily="34" charset="-122"/>
                 <a:cs typeface="Be Vietnam Pro" pitchFamily="34" charset="-120"/>
               </a:rPr>
-              <a:t> MDN</a:t>
-            </a:r>
-            <a:r>
-              <a:rPr lang="en-US" sz="1650" dirty="0" spc="0" kern="0">
-                <a:solidFill>
-                  <a:srgbClr val="9A98A0"/>
-                </a:solidFill>
-                <a:latin typeface="Be Vietnam Pro" pitchFamily="34" charset="0"/>
-                <a:ea typeface="Be Vietnam Pro" pitchFamily="34" charset="-122"/>
-                <a:cs typeface="Be Vietnam Pro" pitchFamily="34" charset="-120"/>
-              </a:rPr>
-              <a:t> nêu</a:t>
-            </a:r>
-            <a:r>
-              <a:rPr lang="en-US" sz="1650" dirty="0" spc="-1" kern="0">
-                <a:solidFill>
-                  <a:srgbClr val="9A98A0"/>
-                </a:solidFill>
-                <a:latin typeface="Be Vietnam Pro" pitchFamily="34" charset="0"/>
-                <a:ea typeface="Be Vietnam Pro" pitchFamily="34" charset="-122"/>
-                <a:cs typeface="Be Vietnam Pro" pitchFamily="34" charset="-120"/>
-              </a:rPr>
-              <a:t> (an ninh)</a:t>
+              <a:t> of privilege</a:t>
             </a:r>
             <a:endParaRPr lang="en-US" sz="1650" dirty="0"/>
           </a:p>
@@ -5724,8 +5768,8 @@
         </p:nvSpPr>
         <p:spPr>
           <a:xfrm>
-            <a:off x="9448800" y="7067550"/>
-            <a:ext cx="3543300" cy="342900"/>
+            <a:off x="1143000" y="7219950"/>
+            <a:ext cx="7696200" cy="361950"/>
           </a:xfrm>
           <a:prstGeom prst="rect">
             <a:avLst/>
@@ -5744,6 +5788,28 @@
               <a:buNone/>
             </a:pPr>
             <a:r>
+              <a:rPr lang="en-US" sz="1650" dirty="0" spc="-4" kern="0">
+                <a:solidFill>
+                  <a:srgbClr val="D8D3C4"/>
+                </a:solidFill>
+                <a:latin typeface="Be Vietnam Pro" pitchFamily="34" charset="0"/>
+                <a:ea typeface="Be Vietnam Pro" pitchFamily="34" charset="-122"/>
+                <a:cs typeface="Be Vietnam Pro" pitchFamily="34" charset="-120"/>
+              </a:rPr>
+              <a:t>Mẹo</a:t>
+            </a:r>
+            <a:r>
+              <a:rPr lang="en-US" sz="1650" dirty="0" spc="0" kern="0">
+                <a:solidFill>
+                  <a:srgbClr val="D8D3C4"/>
+                </a:solidFill>
+                <a:latin typeface="Be Vietnam Pro" pitchFamily="34" charset="0"/>
+                <a:ea typeface="Be Vietnam Pro" pitchFamily="34" charset="-122"/>
+                <a:cs typeface="Be Vietnam Pro" pitchFamily="34" charset="-120"/>
+              </a:rPr>
+              <a:t> nhớ</a:t>
+            </a:r>
+            <a:r>
               <a:rPr lang="en-US" sz="1650" dirty="0" spc="-3" kern="0">
                 <a:solidFill>
                   <a:srgbClr val="D8D3C4"/>
@@ -5752,7 +5818,18 @@
                 <a:ea typeface="Be Vietnam Pro" pitchFamily="34" charset="-122"/>
                 <a:cs typeface="Be Vietnam Pro" pitchFamily="34" charset="-120"/>
               </a:rPr>
-              <a:t>mẹo</a:t>
+              <a:t> sáu</a:t>
+            </a:r>
+            <a:r>
+              <a:rPr lang="en-US" sz="1650" dirty="0" spc="-2" kern="0">
+                <a:solidFill>
+                  <a:srgbClr val="D8D3C4"/>
+                </a:solidFill>
+                <a:latin typeface="Be Vietnam Pro" pitchFamily="34" charset="0"/>
+                <a:ea typeface="Be Vietnam Pro" pitchFamily="34" charset="-122"/>
+                <a:cs typeface="Be Vietnam Pro" pitchFamily="34" charset="-120"/>
+              </a:rPr>
+              <a:t> loại</a:t>
             </a:r>
             <a:r>
               <a:rPr lang="en-US" sz="1650" dirty="0" spc="0" kern="0">
@@ -5763,10 +5840,10 @@
                 <a:ea typeface="Be Vietnam Pro" pitchFamily="34" charset="-122"/>
                 <a:cs typeface="Be Vietnam Pro" pitchFamily="34" charset="-120"/>
               </a:rPr>
-              <a:t> nhớ</a:t>
-            </a:r>
-            <a:r>
-              <a:rPr lang="en-US" sz="1650" dirty="0" spc="-3" kern="0">
+              <a:t> mối</a:t>
+            </a:r>
+            <a:r>
+              <a:rPr lang="en-US" sz="1650" dirty="0" spc="15" kern="0">
                 <a:solidFill>
                   <a:srgbClr val="D8D3C4"/>
                 </a:solidFill>
@@ -5774,7 +5851,40 @@
                 <a:ea typeface="Be Vietnam Pro" pitchFamily="34" charset="-122"/>
                 <a:cs typeface="Be Vietnam Pro" pitchFamily="34" charset="-120"/>
               </a:rPr>
-              <a:t> sáu</a:t>
+              <a:t> đe</a:t>
+            </a:r>
+            <a:r>
+              <a:rPr lang="en-US" sz="1650" dirty="0" spc="-1" kern="0">
+                <a:solidFill>
+                  <a:srgbClr val="D8D3C4"/>
+                </a:solidFill>
+                <a:latin typeface="Be Vietnam Pro" pitchFamily="34" charset="0"/>
+                <a:ea typeface="Be Vietnam Pro" pitchFamily="34" charset="-122"/>
+                <a:cs typeface="Be Vietnam Pro" pitchFamily="34" charset="-120"/>
+              </a:rPr>
+              <a:t> dọa</a:t>
+            </a:r>
+            <a:r>
+              <a:rPr lang="en-US" sz="1650" dirty="0" spc="-8" kern="0">
+                <a:solidFill>
+                  <a:srgbClr val="D8D3C4"/>
+                </a:solidFill>
+                <a:latin typeface="Be Vietnam Pro" pitchFamily="34" charset="0"/>
+                <a:ea typeface="Be Vietnam Pro" pitchFamily="34" charset="-122"/>
+                <a:cs typeface="Be Vietnam Pro" pitchFamily="34" charset="-120"/>
+              </a:rPr>
+              <a:t> về</a:t>
+            </a:r>
+            <a:r>
+              <a:rPr lang="en-US" sz="1650" dirty="0" spc="-1" kern="0">
+                <a:solidFill>
+                  <a:srgbClr val="D8D3C4"/>
+                </a:solidFill>
+                <a:latin typeface="Be Vietnam Pro" pitchFamily="34" charset="0"/>
+                <a:ea typeface="Be Vietnam Pro" pitchFamily="34" charset="-122"/>
+                <a:cs typeface="Be Vietnam Pro" pitchFamily="34" charset="-120"/>
+              </a:rPr>
+              <a:t> an</a:t>
             </a:r>
             <a:r>
               <a:rPr lang="en-US" sz="1650" dirty="0" spc="-2" kern="0">
@@ -5785,40 +5895,7 @@
                 <a:ea typeface="Be Vietnam Pro" pitchFamily="34" charset="-122"/>
                 <a:cs typeface="Be Vietnam Pro" pitchFamily="34" charset="-120"/>
               </a:rPr>
-              <a:t> loại</a:t>
-            </a:r>
-            <a:r>
-              <a:rPr lang="en-US" sz="1650" dirty="0" spc="0" kern="0">
-                <a:solidFill>
-                  <a:srgbClr val="D8D3C4"/>
-                </a:solidFill>
-                <a:latin typeface="Be Vietnam Pro" pitchFamily="34" charset="0"/>
-                <a:ea typeface="Be Vietnam Pro" pitchFamily="34" charset="-122"/>
-                <a:cs typeface="Be Vietnam Pro" pitchFamily="34" charset="-120"/>
-              </a:rPr>
-              <a:t> mối</a:t>
-            </a:r>
-            <a:r>
-              <a:rPr lang="en-US" sz="1650" dirty="0" spc="15" kern="0">
-                <a:solidFill>
-                  <a:srgbClr val="D8D3C4"/>
-                </a:solidFill>
-                <a:latin typeface="Be Vietnam Pro" pitchFamily="34" charset="0"/>
-                <a:ea typeface="Be Vietnam Pro" pitchFamily="34" charset="-122"/>
-                <a:cs typeface="Be Vietnam Pro" pitchFamily="34" charset="-120"/>
-              </a:rPr>
-              <a:t> đe</a:t>
-            </a:r>
-            <a:r>
-              <a:rPr lang="en-US" sz="1650" dirty="0" spc="-1" kern="0">
-                <a:solidFill>
-                  <a:srgbClr val="D8D3C4"/>
-                </a:solidFill>
-                <a:latin typeface="Be Vietnam Pro" pitchFamily="34" charset="0"/>
-                <a:ea typeface="Be Vietnam Pro" pitchFamily="34" charset="-122"/>
-                <a:cs typeface="Be Vietnam Pro" pitchFamily="34" charset="-120"/>
-              </a:rPr>
-              <a:t> dọa</a:t>
+              <a:t> ninh.</a:t>
             </a:r>
             <a:endParaRPr lang="en-US" sz="1650" dirty="0"/>
           </a:p>
@@ -5832,12 +5909,12 @@
         </p:nvSpPr>
         <p:spPr>
           <a:xfrm>
-            <a:off x="13373100" y="5676900"/>
-            <a:ext cx="4000500" cy="1943100"/>
+            <a:off x="9220200" y="5981700"/>
+            <a:ext cx="8153400" cy="1657350"/>
           </a:xfrm>
           <a:prstGeom prst="roundRect">
             <a:avLst>
-              <a:gd name="adj" fmla="val 10784"/>
+              <a:gd name="adj" fmla="val 12644"/>
             </a:avLst>
           </a:prstGeom>
           <a:solidFill>
@@ -5854,8 +5931,8 @@
         </p:nvSpPr>
         <p:spPr>
           <a:xfrm>
-            <a:off x="13601700" y="5886450"/>
-            <a:ext cx="3543300" cy="419100"/>
+            <a:off x="9448800" y="6134100"/>
+            <a:ext cx="7696200" cy="419100"/>
           </a:xfrm>
           <a:prstGeom prst="rect">
             <a:avLst/>
@@ -5893,8 +5970,8 @@
         </p:nvSpPr>
         <p:spPr>
           <a:xfrm>
-            <a:off x="13601700" y="6362700"/>
-            <a:ext cx="3543300" cy="571500"/>
+            <a:off x="9448800" y="6591300"/>
+            <a:ext cx="7696200" cy="571500"/>
           </a:xfrm>
           <a:prstGeom prst="rect">
             <a:avLst/>
@@ -5913,7 +5990,7 @@
               <a:buNone/>
             </a:pPr>
             <a:r>
-              <a:rPr lang="en-US" sz="1650" dirty="0" spc="-9" kern="0">
+              <a:rPr lang="en-US" sz="1650" dirty="0" spc="-1" kern="0">
                 <a:solidFill>
                   <a:srgbClr val="9A98A0"/>
                 </a:solidFill>
@@ -5921,10 +5998,10 @@
                 <a:ea typeface="Be Vietnam Pro" pitchFamily="34" charset="-122"/>
                 <a:cs typeface="Be Vietnam Pro" pitchFamily="34" charset="-120"/>
               </a:rPr>
-              <a:t>tên</a:t>
-            </a:r>
-            <a:r>
-              <a:rPr lang="en-US" sz="1650" dirty="0" spc="0" kern="0">
+              <a:t>Linking,</a:t>
+            </a:r>
+            <a:r>
+              <a:rPr lang="en-US" sz="1650" dirty="0" spc="-3" kern="0">
                 <a:solidFill>
                   <a:srgbClr val="9A98A0"/>
                 </a:solidFill>
@@ -5932,10 +6009,10 @@
                 <a:ea typeface="Be Vietnam Pro" pitchFamily="34" charset="-122"/>
                 <a:cs typeface="Be Vietnam Pro" pitchFamily="34" charset="-120"/>
               </a:rPr>
-              <a:t> khung do</a:t>
-            </a:r>
-            <a:r>
-              <a:rPr lang="en-US" sz="1650" dirty="0" spc="-1" kern="0">
+              <a:t> Identifying,</a:t>
+            </a:r>
+            <a:r>
+              <a:rPr lang="en-US" sz="1650" dirty="0" spc="-7" kern="0">
                 <a:solidFill>
                   <a:srgbClr val="9A98A0"/>
                 </a:solidFill>
@@ -5943,10 +6020,10 @@
                 <a:ea typeface="Be Vietnam Pro" pitchFamily="34" charset="-122"/>
                 <a:cs typeface="Be Vietnam Pro" pitchFamily="34" charset="-120"/>
               </a:rPr>
-              <a:t> MDN</a:t>
-            </a:r>
-            <a:r>
-              <a:rPr lang="en-US" sz="1650" dirty="0" spc="0" kern="0">
+              <a:t> Non-repudiation,</a:t>
+            </a:r>
+            <a:r>
+              <a:rPr lang="en-US" sz="1650" dirty="0" spc="-4" kern="0">
                 <a:solidFill>
                   <a:srgbClr val="9A98A0"/>
                 </a:solidFill>
@@ -5954,10 +6031,10 @@
                 <a:ea typeface="Be Vietnam Pro" pitchFamily="34" charset="-122"/>
                 <a:cs typeface="Be Vietnam Pro" pitchFamily="34" charset="-120"/>
               </a:rPr>
-              <a:t> nêu</a:t>
-            </a:r>
-            <a:r>
-              <a:rPr lang="en-US" sz="1650" dirty="0" spc="5" kern="0">
+              <a:t> Detecting,</a:t>
+            </a:r>
+            <a:r>
+              <a:rPr lang="en-US" sz="1650" dirty="0" spc="-11" kern="0">
                 <a:solidFill>
                   <a:srgbClr val="9A98A0"/>
                 </a:solidFill>
@@ -5965,10 +6042,10 @@
                 <a:ea typeface="Be Vietnam Pro" pitchFamily="34" charset="-122"/>
                 <a:cs typeface="Be Vietnam Pro" pitchFamily="34" charset="-120"/>
               </a:rPr>
-              <a:t> (riêng</a:t>
-            </a:r>
-            <a:r>
-              <a:rPr lang="en-US" sz="1650" dirty="0" spc="35" kern="0">
+              <a:t> Data</a:t>
+            </a:r>
+            <a:r>
+              <a:rPr lang="en-US" sz="1650" dirty="0" spc="-8" kern="0">
                 <a:solidFill>
                   <a:srgbClr val="9A98A0"/>
                 </a:solidFill>
@@ -5976,7 +6053,29 @@
                 <a:ea typeface="Be Vietnam Pro" pitchFamily="34" charset="-122"/>
                 <a:cs typeface="Be Vietnam Pro" pitchFamily="34" charset="-120"/>
               </a:rPr>
-              <a:t> tư)</a:t>
+              <a:t> disclosure,</a:t>
+            </a:r>
+            <a:r>
+              <a:rPr lang="en-US" sz="1650" dirty="0" spc="-11" kern="0">
+                <a:solidFill>
+                  <a:srgbClr val="9A98A0"/>
+                </a:solidFill>
+                <a:latin typeface="Be Vietnam Pro" pitchFamily="34" charset="0"/>
+                <a:ea typeface="Be Vietnam Pro" pitchFamily="34" charset="-122"/>
+                <a:cs typeface="Be Vietnam Pro" pitchFamily="34" charset="-120"/>
+              </a:rPr>
+              <a:t> Unawareness,</a:t>
+            </a:r>
+            <a:r>
+              <a:rPr lang="en-US" sz="1650" dirty="0" spc="-2" kern="0">
+                <a:solidFill>
+                  <a:srgbClr val="9A98A0"/>
+                </a:solidFill>
+                <a:latin typeface="Be Vietnam Pro" pitchFamily="34" charset="0"/>
+                <a:ea typeface="Be Vietnam Pro" pitchFamily="34" charset="-122"/>
+                <a:cs typeface="Be Vietnam Pro" pitchFamily="34" charset="-120"/>
+              </a:rPr>
+              <a:t> Non-compliance</a:t>
             </a:r>
             <a:endParaRPr lang="en-US" sz="1650" dirty="0"/>
           </a:p>
@@ -5990,8 +6089,8 @@
         </p:nvSpPr>
         <p:spPr>
           <a:xfrm>
-            <a:off x="13601700" y="7067550"/>
-            <a:ext cx="3543300" cy="342900"/>
+            <a:off x="9448800" y="7219950"/>
+            <a:ext cx="7696200" cy="361950"/>
           </a:xfrm>
           <a:prstGeom prst="rect">
             <a:avLst/>
@@ -6010,6 +6109,17 @@
               <a:buNone/>
             </a:pPr>
             <a:r>
+              <a:rPr lang="en-US" sz="1650" dirty="0" spc="-4" kern="0">
+                <a:solidFill>
+                  <a:srgbClr val="D8D3C4"/>
+                </a:solidFill>
+                <a:latin typeface="Be Vietnam Pro" pitchFamily="34" charset="0"/>
+                <a:ea typeface="Be Vietnam Pro" pitchFamily="34" charset="-122"/>
+                <a:cs typeface="Be Vietnam Pro" pitchFamily="34" charset="-120"/>
+              </a:rPr>
+              <a:t>Mẹo</a:t>
+            </a:r>
+            <a:r>
               <a:rPr lang="en-US" sz="1650" dirty="0" spc="0" kern="0">
                 <a:solidFill>
                   <a:srgbClr val="D8D3C4"/>
@@ -6018,10 +6128,10 @@
                 <a:ea typeface="Be Vietnam Pro" pitchFamily="34" charset="-122"/>
                 <a:cs typeface="Be Vietnam Pro" pitchFamily="34" charset="-120"/>
               </a:rPr>
-              <a:t>phân</a:t>
-            </a:r>
-            <a:r>
-              <a:rPr lang="en-US" sz="1650" dirty="0" spc="3" kern="0">
+              <a:t> nhớ</a:t>
+            </a:r>
+            <a:r>
+              <a:rPr lang="en-US" sz="1650" dirty="0" spc="-6" kern="0">
                 <a:solidFill>
                   <a:srgbClr val="D8D3C4"/>
                 </a:solidFill>
@@ -6029,7 +6139,18 @@
                 <a:ea typeface="Be Vietnam Pro" pitchFamily="34" charset="-122"/>
                 <a:cs typeface="Be Vietnam Pro" pitchFamily="34" charset="-120"/>
               </a:rPr>
-              <a:t> tích</a:t>
+              <a:t> bảy</a:t>
+            </a:r>
+            <a:r>
+              <a:rPr lang="en-US" sz="1650" dirty="0" spc="-2" kern="0">
+                <a:solidFill>
+                  <a:srgbClr val="D8D3C4"/>
+                </a:solidFill>
+                <a:latin typeface="Be Vietnam Pro" pitchFamily="34" charset="0"/>
+                <a:ea typeface="Be Vietnam Pro" pitchFamily="34" charset="-122"/>
+                <a:cs typeface="Be Vietnam Pro" pitchFamily="34" charset="-120"/>
+              </a:rPr>
+              <a:t> loại</a:t>
             </a:r>
             <a:r>
               <a:rPr lang="en-US" sz="1650" dirty="0" spc="0" kern="0">
@@ -6076,6 +6197,17 @@
               <a:t> về</a:t>
             </a:r>
             <a:r>
+              <a:rPr lang="en-US" sz="1650" dirty="0" spc="-9" kern="0">
+                <a:solidFill>
+                  <a:srgbClr val="D8D3C4"/>
+                </a:solidFill>
+                <a:latin typeface="Be Vietnam Pro" pitchFamily="34" charset="0"/>
+                <a:ea typeface="Be Vietnam Pro" pitchFamily="34" charset="-122"/>
+                <a:cs typeface="Be Vietnam Pro" pitchFamily="34" charset="-120"/>
+              </a:rPr>
+              <a:t> quyền</a:t>
+            </a:r>
+            <a:r>
               <a:rPr lang="en-US" sz="1650" dirty="0" spc="5" kern="0">
                 <a:solidFill>
                   <a:srgbClr val="D8D3C4"/>
@@ -6087,7 +6219,7 @@
               <a:t> riêng</a:t>
             </a:r>
             <a:r>
-              <a:rPr lang="en-US" sz="1650" dirty="0" spc="4" kern="0">
+              <a:rPr lang="en-US" sz="1650" dirty="0" spc="2" kern="0">
                 <a:solidFill>
                   <a:srgbClr val="D8D3C4"/>
                 </a:solidFill>
@@ -6095,7 +6227,7 @@
                 <a:ea typeface="Be Vietnam Pro" pitchFamily="34" charset="-122"/>
                 <a:cs typeface="Be Vietnam Pro" pitchFamily="34" charset="-120"/>
               </a:rPr>
-              <a:t> tư</a:t>
+              <a:t> tư.</a:t>
             </a:r>
             <a:endParaRPr lang="en-US" sz="1650" dirty="0"/>
           </a:p>
@@ -6495,7 +6627,7 @@
       </p:sp>
       <p:sp>
         <p:nvSpPr>
-          <p:cNvPr id="54" name="Connector line-1792390665383-149108112"/>
+          <p:cNvPr id="54" name="Connector line-1792394885300-625791014"/>
           <p:cNvSpPr/>
           <p:nvPr/>
         </p:nvSpPr>

</xml_diff>

<commit_message>
System Design vi: sd-14-022 deck shows DoS on the last slide
Co-Authored-By: Claude Sonnet 5.5 <noreply@anthropic.com>
Claude-Session: https://claude.ai/code/session_01WnjciXNJBLEd8jy3HrG49S
</commit_message>
<xml_diff>
--- a/system-design-101/vi/lessons/sd-14-022/slides/sd-14-022.pptx
+++ b/system-design-101/vi/lessons/sd-14-022/slides/sd-14-022.pptx
@@ -3313,12 +3313,12 @@
         </p:nvSpPr>
         <p:spPr>
           <a:xfrm>
-            <a:off x="914400" y="1485900"/>
-            <a:ext cx="3171825" cy="2095500"/>
+            <a:off x="914400" y="1409700"/>
+            <a:ext cx="3171825" cy="2038350"/>
           </a:xfrm>
           <a:prstGeom prst="roundRect">
             <a:avLst>
-              <a:gd name="adj" fmla="val 10000"/>
+              <a:gd name="adj" fmla="val 10280"/>
             </a:avLst>
           </a:prstGeom>
           <a:solidFill>
@@ -3335,7 +3335,7 @@
         </p:nvSpPr>
         <p:spPr>
           <a:xfrm>
-            <a:off x="1104900" y="1638300"/>
+            <a:off x="1104900" y="1543050"/>
             <a:ext cx="2790825" cy="419100"/>
           </a:xfrm>
           <a:prstGeom prst="rect">
@@ -3374,7 +3374,7 @@
         </p:nvSpPr>
         <p:spPr>
           <a:xfrm>
-            <a:off x="1104900" y="2076450"/>
+            <a:off x="1104900" y="1943100"/>
             <a:ext cx="2790825" cy="800100"/>
           </a:xfrm>
           <a:prstGeom prst="rect">
@@ -3438,7 +3438,7 @@
         </p:nvSpPr>
         <p:spPr>
           <a:xfrm>
-            <a:off x="1104900" y="2933700"/>
+            <a:off x="1104900" y="2781300"/>
             <a:ext cx="2790825" cy="590550"/>
           </a:xfrm>
           <a:prstGeom prst="rect">
@@ -3524,12 +3524,12 @@
         </p:nvSpPr>
         <p:spPr>
           <a:xfrm>
-            <a:off x="4238625" y="1485900"/>
-            <a:ext cx="3171825" cy="2095500"/>
+            <a:off x="4238625" y="1409700"/>
+            <a:ext cx="3171825" cy="2038350"/>
           </a:xfrm>
           <a:prstGeom prst="roundRect">
             <a:avLst>
-              <a:gd name="adj" fmla="val 10000"/>
+              <a:gd name="adj" fmla="val 10280"/>
             </a:avLst>
           </a:prstGeom>
           <a:solidFill>
@@ -3546,7 +3546,7 @@
         </p:nvSpPr>
         <p:spPr>
           <a:xfrm>
-            <a:off x="4429125" y="1638300"/>
+            <a:off x="4429125" y="1543050"/>
             <a:ext cx="2790825" cy="419100"/>
           </a:xfrm>
           <a:prstGeom prst="rect">
@@ -3585,7 +3585,7 @@
         </p:nvSpPr>
         <p:spPr>
           <a:xfrm>
-            <a:off x="4429125" y="2076450"/>
+            <a:off x="4429125" y="1943100"/>
             <a:ext cx="2790825" cy="800100"/>
           </a:xfrm>
           <a:prstGeom prst="rect">
@@ -3649,7 +3649,7 @@
         </p:nvSpPr>
         <p:spPr>
           <a:xfrm>
-            <a:off x="4429125" y="2933700"/>
+            <a:off x="4429125" y="2781300"/>
             <a:ext cx="2790825" cy="590550"/>
           </a:xfrm>
           <a:prstGeom prst="rect">
@@ -3757,12 +3757,12 @@
         </p:nvSpPr>
         <p:spPr>
           <a:xfrm>
-            <a:off x="7562850" y="1485900"/>
-            <a:ext cx="3171825" cy="2095500"/>
+            <a:off x="7562850" y="1409700"/>
+            <a:ext cx="3171825" cy="2038350"/>
           </a:xfrm>
           <a:prstGeom prst="roundRect">
             <a:avLst>
-              <a:gd name="adj" fmla="val 10000"/>
+              <a:gd name="adj" fmla="val 10280"/>
             </a:avLst>
           </a:prstGeom>
           <a:solidFill>
@@ -3779,7 +3779,7 @@
         </p:nvSpPr>
         <p:spPr>
           <a:xfrm>
-            <a:off x="7753350" y="1638300"/>
+            <a:off x="7753350" y="1543050"/>
             <a:ext cx="2790825" cy="419100"/>
           </a:xfrm>
           <a:prstGeom prst="rect">
@@ -3818,7 +3818,7 @@
         </p:nvSpPr>
         <p:spPr>
           <a:xfrm>
-            <a:off x="7753350" y="2076450"/>
+            <a:off x="7753350" y="1943100"/>
             <a:ext cx="2790825" cy="800100"/>
           </a:xfrm>
           <a:prstGeom prst="rect">
@@ -3893,7 +3893,7 @@
         </p:nvSpPr>
         <p:spPr>
           <a:xfrm>
-            <a:off x="7753350" y="2933700"/>
+            <a:off x="7753350" y="2781300"/>
             <a:ext cx="2790825" cy="590550"/>
           </a:xfrm>
           <a:prstGeom prst="rect">
@@ -4001,12 +4001,12 @@
         </p:nvSpPr>
         <p:spPr>
           <a:xfrm>
-            <a:off x="10887075" y="1485900"/>
-            <a:ext cx="3171825" cy="2095500"/>
+            <a:off x="10887075" y="1409700"/>
+            <a:ext cx="3171825" cy="2038350"/>
           </a:xfrm>
           <a:prstGeom prst="roundRect">
             <a:avLst>
-              <a:gd name="adj" fmla="val 10000"/>
+              <a:gd name="adj" fmla="val 10280"/>
             </a:avLst>
           </a:prstGeom>
           <a:solidFill>
@@ -4023,7 +4023,7 @@
         </p:nvSpPr>
         <p:spPr>
           <a:xfrm>
-            <a:off x="11077575" y="1638300"/>
+            <a:off x="11077575" y="1543050"/>
             <a:ext cx="2790825" cy="419100"/>
           </a:xfrm>
           <a:prstGeom prst="rect">
@@ -4062,7 +4062,7 @@
         </p:nvSpPr>
         <p:spPr>
           <a:xfrm>
-            <a:off x="11077575" y="2076450"/>
+            <a:off x="11077575" y="1943100"/>
             <a:ext cx="2790825" cy="800100"/>
           </a:xfrm>
           <a:prstGeom prst="rect">
@@ -4126,7 +4126,7 @@
         </p:nvSpPr>
         <p:spPr>
           <a:xfrm>
-            <a:off x="11077575" y="2933700"/>
+            <a:off x="11077575" y="2781300"/>
             <a:ext cx="2790825" cy="590550"/>
           </a:xfrm>
           <a:prstGeom prst="rect">
@@ -4201,12 +4201,12 @@
         </p:nvSpPr>
         <p:spPr>
           <a:xfrm>
-            <a:off x="14211300" y="1485900"/>
-            <a:ext cx="3162300" cy="2095500"/>
+            <a:off x="14211300" y="1409700"/>
+            <a:ext cx="3162300" cy="2038350"/>
           </a:xfrm>
           <a:prstGeom prst="roundRect">
             <a:avLst>
-              <a:gd name="adj" fmla="val 10000"/>
+              <a:gd name="adj" fmla="val 10280"/>
             </a:avLst>
           </a:prstGeom>
           <a:solidFill>
@@ -4223,7 +4223,7 @@
         </p:nvSpPr>
         <p:spPr>
           <a:xfrm>
-            <a:off x="14401800" y="1638300"/>
+            <a:off x="14401800" y="1543050"/>
             <a:ext cx="2781300" cy="419100"/>
           </a:xfrm>
           <a:prstGeom prst="rect">
@@ -4262,7 +4262,7 @@
         </p:nvSpPr>
         <p:spPr>
           <a:xfrm>
-            <a:off x="14401800" y="2076450"/>
+            <a:off x="14401800" y="1943100"/>
             <a:ext cx="2781300" cy="800100"/>
           </a:xfrm>
           <a:prstGeom prst="rect">
@@ -4304,7 +4304,7 @@
         </p:nvSpPr>
         <p:spPr>
           <a:xfrm>
-            <a:off x="14401800" y="2933700"/>
+            <a:off x="14401800" y="2781300"/>
             <a:ext cx="2781300" cy="590550"/>
           </a:xfrm>
           <a:prstGeom prst="rect">
@@ -4412,12 +4412,12 @@
         </p:nvSpPr>
         <p:spPr>
           <a:xfrm>
-            <a:off x="914400" y="3733800"/>
-            <a:ext cx="3171825" cy="2095500"/>
+            <a:off x="914400" y="3600450"/>
+            <a:ext cx="3171825" cy="2038350"/>
           </a:xfrm>
           <a:prstGeom prst="roundRect">
             <a:avLst>
-              <a:gd name="adj" fmla="val 10000"/>
+              <a:gd name="adj" fmla="val 10280"/>
             </a:avLst>
           </a:prstGeom>
           <a:solidFill>
@@ -4434,7 +4434,7 @@
         </p:nvSpPr>
         <p:spPr>
           <a:xfrm>
-            <a:off x="1104900" y="3886200"/>
+            <a:off x="1104900" y="3733800"/>
             <a:ext cx="2790825" cy="419100"/>
           </a:xfrm>
           <a:prstGeom prst="rect">
@@ -4473,7 +4473,7 @@
         </p:nvSpPr>
         <p:spPr>
           <a:xfrm>
-            <a:off x="1104900" y="4324350"/>
+            <a:off x="1104900" y="4133850"/>
             <a:ext cx="2790825" cy="800100"/>
           </a:xfrm>
           <a:prstGeom prst="rect">
@@ -4526,7 +4526,7 @@
         </p:nvSpPr>
         <p:spPr>
           <a:xfrm>
-            <a:off x="1104900" y="5181600"/>
+            <a:off x="1104900" y="4972050"/>
             <a:ext cx="2790825" cy="590550"/>
           </a:xfrm>
           <a:prstGeom prst="rect">
@@ -4645,12 +4645,12 @@
         </p:nvSpPr>
         <p:spPr>
           <a:xfrm>
-            <a:off x="4238625" y="3733800"/>
-            <a:ext cx="3171825" cy="2095500"/>
+            <a:off x="4238625" y="3600450"/>
+            <a:ext cx="3171825" cy="2038350"/>
           </a:xfrm>
           <a:prstGeom prst="roundRect">
             <a:avLst>
-              <a:gd name="adj" fmla="val 10000"/>
+              <a:gd name="adj" fmla="val 10280"/>
             </a:avLst>
           </a:prstGeom>
           <a:solidFill>
@@ -4667,7 +4667,7 @@
         </p:nvSpPr>
         <p:spPr>
           <a:xfrm>
-            <a:off x="4429125" y="3886200"/>
+            <a:off x="4429125" y="3733800"/>
             <a:ext cx="2790825" cy="419100"/>
           </a:xfrm>
           <a:prstGeom prst="rect">
@@ -4706,7 +4706,7 @@
         </p:nvSpPr>
         <p:spPr>
           <a:xfrm>
-            <a:off x="4429125" y="4324350"/>
+            <a:off x="4429125" y="4133850"/>
             <a:ext cx="2790825" cy="800100"/>
           </a:xfrm>
           <a:prstGeom prst="rect">
@@ -4770,7 +4770,7 @@
         </p:nvSpPr>
         <p:spPr>
           <a:xfrm>
-            <a:off x="4429125" y="5181600"/>
+            <a:off x="4429125" y="4972050"/>
             <a:ext cx="2790825" cy="590550"/>
           </a:xfrm>
           <a:prstGeom prst="rect">
@@ -4867,12 +4867,12 @@
         </p:nvSpPr>
         <p:spPr>
           <a:xfrm>
-            <a:off x="7562850" y="3733800"/>
-            <a:ext cx="3171825" cy="2095500"/>
+            <a:off x="7562850" y="3600450"/>
+            <a:ext cx="3171825" cy="2038350"/>
           </a:xfrm>
           <a:prstGeom prst="roundRect">
             <a:avLst>
-              <a:gd name="adj" fmla="val 10000"/>
+              <a:gd name="adj" fmla="val 10280"/>
             </a:avLst>
           </a:prstGeom>
           <a:solidFill>
@@ -4889,7 +4889,7 @@
         </p:nvSpPr>
         <p:spPr>
           <a:xfrm>
-            <a:off x="7753350" y="3886200"/>
+            <a:off x="7753350" y="3733800"/>
             <a:ext cx="2790825" cy="419100"/>
           </a:xfrm>
           <a:prstGeom prst="rect">
@@ -4928,7 +4928,7 @@
         </p:nvSpPr>
         <p:spPr>
           <a:xfrm>
-            <a:off x="7753350" y="4324350"/>
+            <a:off x="7753350" y="4133850"/>
             <a:ext cx="2790825" cy="800100"/>
           </a:xfrm>
           <a:prstGeom prst="rect">
@@ -5014,7 +5014,7 @@
         </p:nvSpPr>
         <p:spPr>
           <a:xfrm>
-            <a:off x="7753350" y="5181600"/>
+            <a:off x="7753350" y="4972050"/>
             <a:ext cx="2790825" cy="590550"/>
           </a:xfrm>
           <a:prstGeom prst="rect">
@@ -5111,12 +5111,12 @@
         </p:nvSpPr>
         <p:spPr>
           <a:xfrm>
-            <a:off x="10887075" y="3733800"/>
-            <a:ext cx="3171825" cy="2095500"/>
+            <a:off x="10887075" y="3600450"/>
+            <a:ext cx="3171825" cy="2038350"/>
           </a:xfrm>
           <a:prstGeom prst="roundRect">
             <a:avLst>
-              <a:gd name="adj" fmla="val 10000"/>
+              <a:gd name="adj" fmla="val 10280"/>
             </a:avLst>
           </a:prstGeom>
           <a:solidFill>
@@ -5133,7 +5133,7 @@
         </p:nvSpPr>
         <p:spPr>
           <a:xfrm>
-            <a:off x="11077575" y="3886200"/>
+            <a:off x="11077575" y="3733800"/>
             <a:ext cx="2790825" cy="419100"/>
           </a:xfrm>
           <a:prstGeom prst="rect">
@@ -5172,7 +5172,7 @@
         </p:nvSpPr>
         <p:spPr>
           <a:xfrm>
-            <a:off x="11077575" y="4324350"/>
+            <a:off x="11077575" y="4133850"/>
             <a:ext cx="2790825" cy="800100"/>
           </a:xfrm>
           <a:prstGeom prst="rect">
@@ -5247,7 +5247,7 @@
         </p:nvSpPr>
         <p:spPr>
           <a:xfrm>
-            <a:off x="11077575" y="5181600"/>
+            <a:off x="11077575" y="4972050"/>
             <a:ext cx="2790825" cy="590550"/>
           </a:xfrm>
           <a:prstGeom prst="rect">
@@ -5355,12 +5355,12 @@
         </p:nvSpPr>
         <p:spPr>
           <a:xfrm>
-            <a:off x="14211300" y="3733800"/>
-            <a:ext cx="3162300" cy="2095500"/>
+            <a:off x="14211300" y="3600450"/>
+            <a:ext cx="3162300" cy="2038350"/>
           </a:xfrm>
           <a:prstGeom prst="roundRect">
             <a:avLst>
-              <a:gd name="adj" fmla="val 10000"/>
+              <a:gd name="adj" fmla="val 10280"/>
             </a:avLst>
           </a:prstGeom>
           <a:solidFill>
@@ -5377,7 +5377,7 @@
         </p:nvSpPr>
         <p:spPr>
           <a:xfrm>
-            <a:off x="14401800" y="3886200"/>
+            <a:off x="14401800" y="3733800"/>
             <a:ext cx="2781300" cy="419100"/>
           </a:xfrm>
           <a:prstGeom prst="rect">
@@ -5416,7 +5416,7 @@
         </p:nvSpPr>
         <p:spPr>
           <a:xfrm>
-            <a:off x="14401800" y="4324350"/>
+            <a:off x="14401800" y="4133850"/>
             <a:ext cx="2781300" cy="800100"/>
           </a:xfrm>
           <a:prstGeom prst="rect">
@@ -5480,7 +5480,7 @@
         </p:nvSpPr>
         <p:spPr>
           <a:xfrm>
-            <a:off x="14401800" y="5181600"/>
+            <a:off x="14401800" y="4972050"/>
             <a:ext cx="2781300" cy="590550"/>
           </a:xfrm>
           <a:prstGeom prst="rect">
@@ -5577,12 +5577,12 @@
         </p:nvSpPr>
         <p:spPr>
           <a:xfrm>
-            <a:off x="914400" y="5981700"/>
-            <a:ext cx="8153400" cy="1657350"/>
+            <a:off x="5067300" y="5791200"/>
+            <a:ext cx="6076950" cy="1752600"/>
           </a:xfrm>
           <a:prstGeom prst="roundRect">
             <a:avLst>
-              <a:gd name="adj" fmla="val 12644"/>
+              <a:gd name="adj" fmla="val 11957"/>
             </a:avLst>
           </a:prstGeom>
           <a:solidFill>
@@ -5599,8 +5599,8 @@
         </p:nvSpPr>
         <p:spPr>
           <a:xfrm>
-            <a:off x="1143000" y="6134100"/>
-            <a:ext cx="7696200" cy="419100"/>
+            <a:off x="5295900" y="5943600"/>
+            <a:ext cx="5619750" cy="419100"/>
           </a:xfrm>
           <a:prstGeom prst="rect">
             <a:avLst/>
@@ -5638,8 +5638,8 @@
         </p:nvSpPr>
         <p:spPr>
           <a:xfrm>
-            <a:off x="1143000" y="6591300"/>
-            <a:ext cx="7696200" cy="571500"/>
+            <a:off x="5295900" y="6381750"/>
+            <a:ext cx="5619750" cy="571500"/>
           </a:xfrm>
           <a:prstGeom prst="rect">
             <a:avLst/>
@@ -5768,8 +5768,8 @@
         </p:nvSpPr>
         <p:spPr>
           <a:xfrm>
-            <a:off x="1143000" y="7219950"/>
-            <a:ext cx="7696200" cy="361950"/>
+            <a:off x="5295900" y="7048500"/>
+            <a:ext cx="5619750" cy="361950"/>
           </a:xfrm>
           <a:prstGeom prst="rect">
             <a:avLst/>
@@ -5909,12 +5909,12 @@
         </p:nvSpPr>
         <p:spPr>
           <a:xfrm>
-            <a:off x="9220200" y="5981700"/>
-            <a:ext cx="8153400" cy="1657350"/>
+            <a:off x="11296650" y="5791200"/>
+            <a:ext cx="6076950" cy="1752600"/>
           </a:xfrm>
           <a:prstGeom prst="roundRect">
             <a:avLst>
-              <a:gd name="adj" fmla="val 12644"/>
+              <a:gd name="adj" fmla="val 11957"/>
             </a:avLst>
           </a:prstGeom>
           <a:solidFill>
@@ -5931,8 +5931,8 @@
         </p:nvSpPr>
         <p:spPr>
           <a:xfrm>
-            <a:off x="9448800" y="6134100"/>
-            <a:ext cx="7696200" cy="419100"/>
+            <a:off x="11525250" y="5943600"/>
+            <a:ext cx="5619750" cy="419100"/>
           </a:xfrm>
           <a:prstGeom prst="rect">
             <a:avLst/>
@@ -5970,8 +5970,8 @@
         </p:nvSpPr>
         <p:spPr>
           <a:xfrm>
-            <a:off x="9448800" y="6591300"/>
-            <a:ext cx="7696200" cy="571500"/>
+            <a:off x="11525250" y="6381750"/>
+            <a:ext cx="5619750" cy="571500"/>
           </a:xfrm>
           <a:prstGeom prst="rect">
             <a:avLst/>
@@ -6089,8 +6089,8 @@
         </p:nvSpPr>
         <p:spPr>
           <a:xfrm>
-            <a:off x="9448800" y="7219950"/>
-            <a:ext cx="7696200" cy="361950"/>
+            <a:off x="11525250" y="7048500"/>
+            <a:ext cx="5619750" cy="361950"/>
           </a:xfrm>
           <a:prstGeom prst="rect">
             <a:avLst/>
@@ -6965,6 +6965,283 @@
         </p:nvSpPr>
         <p:spPr>
           <a:xfrm>
+            <a:off x="914400" y="5791200"/>
+            <a:ext cx="4000500" cy="1752600"/>
+          </a:xfrm>
+          <a:prstGeom prst="roundRect">
+            <a:avLst>
+              <a:gd name="adj" fmla="val 11957"/>
+            </a:avLst>
+          </a:prstGeom>
+          <a:solidFill>
+            <a:srgbClr val="1E212B"/>
+          </a:solidFill>
+          <a:ln/>
+        </p:spPr>
+      </p:sp>
+      <p:sp>
+        <p:nvSpPr>
+          <p:cNvPr id="67" name="Text 65"/>
+          <p:cNvSpPr/>
+          <p:nvPr/>
+        </p:nvSpPr>
+        <p:spPr>
+          <a:xfrm>
+            <a:off x="1143000" y="5943600"/>
+            <a:ext cx="3543300" cy="419100"/>
+          </a:xfrm>
+          <a:prstGeom prst="rect">
+            <a:avLst/>
+          </a:prstGeom>
+          <a:noFill/>
+          <a:ln/>
+        </p:spPr>
+        <p:txBody>
+          <a:bodyPr wrap="square" lIns="0" tIns="0" rIns="0" bIns="0" rtlCol="0" anchor="t"/>
+          <a:lstStyle/>
+          <a:p>
+            <a:pPr algn="l" indent="0" marL="0">
+              <a:buNone/>
+            </a:pPr>
+            <a:r>
+              <a:rPr lang="en-US" sz="2400" dirty="0" spc="2" kern="0">
+                <a:solidFill>
+                  <a:srgbClr val="3DD6A0"/>
+                </a:solidFill>
+                <a:latin typeface="Bricolage Grotesque ExtraBold" pitchFamily="34" charset="0"/>
+                <a:ea typeface="Bricolage Grotesque ExtraBold" pitchFamily="34" charset="-122"/>
+                <a:cs typeface="Bricolage Grotesque ExtraBold" pitchFamily="34" charset="-120"/>
+              </a:rPr>
+              <a:t>DoS</a:t>
+            </a:r>
+            <a:endParaRPr lang="en-US" sz="2400" dirty="0"/>
+          </a:p>
+        </p:txBody>
+      </p:sp>
+      <p:sp>
+        <p:nvSpPr>
+          <p:cNvPr id="68" name="Text 66"/>
+          <p:cNvSpPr/>
+          <p:nvPr/>
+        </p:nvSpPr>
+        <p:spPr>
+          <a:xfrm>
+            <a:off x="1143000" y="6381750"/>
+            <a:ext cx="3543300" cy="285750"/>
+          </a:xfrm>
+          <a:prstGeom prst="rect">
+            <a:avLst/>
+          </a:prstGeom>
+          <a:noFill/>
+          <a:ln/>
+        </p:spPr>
+        <p:txBody>
+          <a:bodyPr wrap="square" lIns="0" tIns="11509" rIns="0" bIns="-11509" rtlCol="0" anchor="t"/>
+          <a:lstStyle/>
+          <a:p>
+            <a:pPr algn="l" indent="0" marL="0">
+              <a:lnSpc>
+                <a:spcPts val="2063"/>
+              </a:lnSpc>
+              <a:buNone/>
+            </a:pPr>
+            <a:r>
+              <a:rPr lang="en-US" sz="1650" dirty="0" spc="-2" kern="0">
+                <a:solidFill>
+                  <a:srgbClr val="9A98A0"/>
+                </a:solidFill>
+                <a:latin typeface="Be Vietnam Pro" pitchFamily="34" charset="0"/>
+                <a:ea typeface="Be Vietnam Pro" pitchFamily="34" charset="-122"/>
+                <a:cs typeface="Be Vietnam Pro" pitchFamily="34" charset="-120"/>
+              </a:rPr>
+              <a:t>Denial</a:t>
+            </a:r>
+            <a:r>
+              <a:rPr lang="en-US" sz="1650" dirty="0" spc="0" kern="0">
+                <a:solidFill>
+                  <a:srgbClr val="9A98A0"/>
+                </a:solidFill>
+                <a:latin typeface="Be Vietnam Pro" pitchFamily="34" charset="0"/>
+                <a:ea typeface="Be Vietnam Pro" pitchFamily="34" charset="-122"/>
+                <a:cs typeface="Be Vietnam Pro" pitchFamily="34" charset="-120"/>
+              </a:rPr>
+              <a:t> of Service</a:t>
+            </a:r>
+            <a:endParaRPr lang="en-US" sz="1650" dirty="0"/>
+          </a:p>
+        </p:txBody>
+      </p:sp>
+      <p:sp>
+        <p:nvSpPr>
+          <p:cNvPr id="69" name="Text 67"/>
+          <p:cNvSpPr/>
+          <p:nvPr/>
+        </p:nvSpPr>
+        <p:spPr>
+          <a:xfrm>
+            <a:off x="1143000" y="6743700"/>
+            <a:ext cx="3543300" cy="590550"/>
+          </a:xfrm>
+          <a:prstGeom prst="rect">
+            <a:avLst/>
+          </a:prstGeom>
+          <a:noFill/>
+          <a:ln/>
+        </p:spPr>
+        <p:txBody>
+          <a:bodyPr wrap="square" lIns="0" tIns="8906" rIns="0" bIns="-8906" rtlCol="0" anchor="t"/>
+          <a:lstStyle/>
+          <a:p>
+            <a:pPr algn="l" indent="0" marL="0">
+              <a:lnSpc>
+                <a:spcPts val="2145"/>
+              </a:lnSpc>
+              <a:buNone/>
+            </a:pPr>
+            <a:r>
+              <a:rPr lang="en-US" sz="1650" dirty="0" spc="-20" kern="0">
+                <a:solidFill>
+                  <a:srgbClr val="D8D3C4"/>
+                </a:solidFill>
+                <a:latin typeface="Be Vietnam Pro" pitchFamily="34" charset="0"/>
+                <a:ea typeface="Be Vietnam Pro" pitchFamily="34" charset="-122"/>
+                <a:cs typeface="Be Vietnam Pro" pitchFamily="34" charset="-120"/>
+              </a:rPr>
+              <a:t>Làm</a:t>
+            </a:r>
+            <a:r>
+              <a:rPr lang="en-US" sz="1650" dirty="0" spc="0" kern="0">
+                <a:solidFill>
+                  <a:srgbClr val="D8D3C4"/>
+                </a:solidFill>
+                <a:latin typeface="Be Vietnam Pro" pitchFamily="34" charset="0"/>
+                <a:ea typeface="Be Vietnam Pro" pitchFamily="34" charset="-122"/>
+                <a:cs typeface="Be Vietnam Pro" pitchFamily="34" charset="-120"/>
+              </a:rPr>
+              <a:t> cạn</a:t>
+            </a:r>
+            <a:r>
+              <a:rPr lang="en-US" sz="1650" dirty="0" spc="-5" kern="0">
+                <a:solidFill>
+                  <a:srgbClr val="D8D3C4"/>
+                </a:solidFill>
+                <a:latin typeface="Be Vietnam Pro" pitchFamily="34" charset="0"/>
+                <a:ea typeface="Be Vietnam Pro" pitchFamily="34" charset="-122"/>
+                <a:cs typeface="Be Vietnam Pro" pitchFamily="34" charset="-120"/>
+              </a:rPr>
+              <a:t> tài</a:t>
+            </a:r>
+            <a:r>
+              <a:rPr lang="en-US" sz="1650" dirty="0" spc="-9" kern="0">
+                <a:solidFill>
+                  <a:srgbClr val="D8D3C4"/>
+                </a:solidFill>
+                <a:latin typeface="Be Vietnam Pro" pitchFamily="34" charset="0"/>
+                <a:ea typeface="Be Vietnam Pro" pitchFamily="34" charset="-122"/>
+                <a:cs typeface="Be Vietnam Pro" pitchFamily="34" charset="-120"/>
+              </a:rPr>
+              <a:t> nguyên</a:t>
+            </a:r>
+            <a:r>
+              <a:rPr lang="en-US" sz="1650" dirty="0" spc="-5" kern="0">
+                <a:solidFill>
+                  <a:srgbClr val="D8D3C4"/>
+                </a:solidFill>
+                <a:latin typeface="Be Vietnam Pro" pitchFamily="34" charset="0"/>
+                <a:ea typeface="Be Vietnam Pro" pitchFamily="34" charset="-122"/>
+                <a:cs typeface="Be Vietnam Pro" pitchFamily="34" charset="-120"/>
+              </a:rPr>
+              <a:t> máy</a:t>
+            </a:r>
+            <a:r>
+              <a:rPr lang="en-US" sz="1650" dirty="0" spc="0" kern="0">
+                <a:solidFill>
+                  <a:srgbClr val="D8D3C4"/>
+                </a:solidFill>
+                <a:latin typeface="Be Vietnam Pro" pitchFamily="34" charset="0"/>
+                <a:ea typeface="Be Vietnam Pro" pitchFamily="34" charset="-122"/>
+                <a:cs typeface="Be Vietnam Pro" pitchFamily="34" charset="-120"/>
+              </a:rPr>
+              <a:t> chủ,</a:t>
+            </a:r>
+            <a:r>
+              <a:rPr lang="en-US" sz="1650" dirty="0" spc="4" kern="0">
+                <a:solidFill>
+                  <a:srgbClr val="D8D3C4"/>
+                </a:solidFill>
+                <a:latin typeface="Be Vietnam Pro" pitchFamily="34" charset="0"/>
+                <a:ea typeface="Be Vietnam Pro" pitchFamily="34" charset="-122"/>
+                <a:cs typeface="Be Vietnam Pro" pitchFamily="34" charset="-120"/>
+              </a:rPr>
+              <a:t> người</a:t>
+            </a:r>
+            <a:r>
+              <a:rPr lang="en-US" sz="1650" dirty="0" spc="0" kern="0">
+                <a:solidFill>
+                  <a:srgbClr val="D8D3C4"/>
+                </a:solidFill>
+                <a:latin typeface="Be Vietnam Pro" pitchFamily="34" charset="0"/>
+                <a:ea typeface="Be Vietnam Pro" pitchFamily="34" charset="-122"/>
+                <a:cs typeface="Be Vietnam Pro" pitchFamily="34" charset="-120"/>
+              </a:rPr>
+              <a:t> dùng</a:t>
+            </a:r>
+            <a:r>
+              <a:rPr lang="en-US" sz="1650" dirty="0" spc="-3" kern="0">
+                <a:solidFill>
+                  <a:srgbClr val="D8D3C4"/>
+                </a:solidFill>
+                <a:latin typeface="Be Vietnam Pro" pitchFamily="34" charset="0"/>
+                <a:ea typeface="Be Vietnam Pro" pitchFamily="34" charset="-122"/>
+                <a:cs typeface="Be Vietnam Pro" pitchFamily="34" charset="-120"/>
+              </a:rPr>
+              <a:t> thật</a:t>
+            </a:r>
+            <a:r>
+              <a:rPr lang="en-US" sz="1650" dirty="0" spc="0" kern="0">
+                <a:solidFill>
+                  <a:srgbClr val="D8D3C4"/>
+                </a:solidFill>
+                <a:latin typeface="Be Vietnam Pro" pitchFamily="34" charset="0"/>
+                <a:ea typeface="Be Vietnam Pro" pitchFamily="34" charset="-122"/>
+                <a:cs typeface="Be Vietnam Pro" pitchFamily="34" charset="-120"/>
+              </a:rPr>
+              <a:t> không</a:t>
+            </a:r>
+            <a:r>
+              <a:rPr lang="en-US" sz="1650" dirty="0" spc="-7" kern="0">
+                <a:solidFill>
+                  <a:srgbClr val="D8D3C4"/>
+                </a:solidFill>
+                <a:latin typeface="Be Vietnam Pro" pitchFamily="34" charset="0"/>
+                <a:ea typeface="Be Vietnam Pro" pitchFamily="34" charset="-122"/>
+                <a:cs typeface="Be Vietnam Pro" pitchFamily="34" charset="-120"/>
+              </a:rPr>
+              <a:t> vào</a:t>
+            </a:r>
+            <a:r>
+              <a:rPr lang="en-US" sz="1650" dirty="0" spc="5" kern="0">
+                <a:solidFill>
+                  <a:srgbClr val="D8D3C4"/>
+                </a:solidFill>
+                <a:latin typeface="Be Vietnam Pro" pitchFamily="34" charset="0"/>
+                <a:ea typeface="Be Vietnam Pro" pitchFamily="34" charset="-122"/>
+                <a:cs typeface="Be Vietnam Pro" pitchFamily="34" charset="-120"/>
+              </a:rPr>
+              <a:t> được.</a:t>
+            </a:r>
+            <a:endParaRPr lang="en-US" sz="1650" dirty="0"/>
+          </a:p>
+        </p:txBody>
+      </p:sp>
+      <p:sp>
+        <p:nvSpPr>
+          <p:cNvPr id="70" name="Shape 68"/>
+          <p:cNvSpPr/>
+          <p:nvPr/>
+        </p:nvSpPr>
+        <p:spPr>
+          <a:xfrm>
             <a:off x="15983712" y="9076331"/>
             <a:ext cx="1645920" cy="552301"/>
           </a:xfrm>
@@ -6983,7 +7260,7 @@
       </p:sp>
       <p:pic>
         <p:nvPicPr>
-          <p:cNvPr id="67" name="Moda image moda-export-watermark-9797e441-c75f-46c8-b5dc-4a89357124c9" descr="">    </p:cNvPr>
+          <p:cNvPr id="71" name="Moda image moda-export-watermark-9797e441-c75f-46c8-b5dc-4a89357124c9" descr="">    </p:cNvPr>
           <p:cNvPicPr>
             <a:picLocks noChangeAspect="1"/>
           </p:cNvPicPr>

</xml_diff>